<commit_message>
Cập nhật slide theo kết quả chạy thật T10: 12/12 kịch bản, thay hạn chế đã khắc phục
</commit_message>
<xml_diff>
--- a/docs/Slide-BaoVe-Integration-Service.pptx
+++ b/docs/Slide-BaoVe-Integration-Service.pptx
@@ -11597,7 +11597,7 @@
                 <a:ea typeface="Calibri" pitchFamily="34" charset="-122"/>
                 <a:cs typeface="Calibri" pitchFamily="34" charset="-120"/>
               </a:rPr>
-              <a:t>Kịch bản T10 chưa có bản ghi chạy thật</a:t>
+              <a:t>Chưa có cảnh báo tự động</a:t>
             </a:r>
             <a:endParaRPr lang="en-US" sz="1350" dirty="0"/>
           </a:p>
@@ -11639,7 +11639,7 @@
                 <a:ea typeface="Calibri" pitchFamily="34" charset="-122"/>
                 <a:cs typeface="Calibri" pitchFamily="34" charset="-120"/>
               </a:rPr>
-              <a:t>Cơ chế thử lại đã kiểm chứng bằng 4 ca tự động với WireMock; lab chưa bật chế độ lỗi mô phỏng</a:t>
+              <a:t>Số lượng dead-letter và độ tồn đọng inbox hiện phải xem thủ công</a:t>
             </a:r>
             <a:endParaRPr lang="en-US" sz="1250" dirty="0"/>
           </a:p>
@@ -13275,7 +13275,7 @@
                 <a:ea typeface="Cambria" pitchFamily="34" charset="-122"/>
                 <a:cs typeface="Cambria" pitchFamily="34" charset="-120"/>
               </a:rPr>
-              <a:t>11/12</a:t>
+              <a:t>12/12</a:t>
             </a:r>
             <a:endParaRPr lang="en-US" sz="3000" dirty="0"/>
           </a:p>

</xml_diff>